<commit_message>
Clarify pinned AKS demo version
</commit_message>
<xml_diff>
--- a/PRESENTATION.pptx
+++ b/PRESENTATION.pptx
@@ -1130,6 +1130,12 @@
           <a:p>
             <a:r>
               <a:rPr sz="1100"/>
+              <a:t># Pinned demo Kubernetes version for reproducibility</a:t>
+            </a:r>
+          </a:p>
+          <a:p>
+            <a:r>
+              <a:rPr sz="1100"/>
               <a:t>az aks create -g $RG -n $AKS -l $LOC \</a:t>
             </a:r>
           </a:p>
@@ -2006,6 +2012,12 @@
           <a:p>
             <a:r>
               <a:rPr sz="1100"/>
+              <a:t># Pinned demo Kubernetes version for reproducibility</a:t>
+            </a:r>
+          </a:p>
+          <a:p>
+            <a:r>
+              <a:rPr sz="1100"/>
               <a:t>az aks create -g $RG -n $AKS -l $LOC \</a:t>
             </a:r>
           </a:p>
@@ -2762,7 +2774,7 @@
           <a:p>
             <a:r>
               <a:rPr sz="1100"/>
-              <a:t># 1. Create resource group + AKS (Free tier, K8s 1.34.7, Sweden Central)</a:t>
+              <a:t># 1. Create resource group + AKS (Free tier, pinned K8s 1.34.7, Sweden Central)</a:t>
             </a:r>
           </a:p>
           <a:p>
@@ -21304,7 +21316,7 @@
                 </a:solidFill>
                 <a:latin typeface="Calibri"/>
               </a:rPr>
-              <a:t>Ensure the K8s-configuration provider + extension CLI are available</a:t>
+              <a:t>Pinned demo Kubernetes version for reproducibility</a:t>
             </a:r>
           </a:p>
         </p:txBody>
@@ -21417,7 +21429,7 @@
                 </a:solidFill>
                 <a:latin typeface="Calibri"/>
               </a:rPr>
-              <a:t>Install the managed Argo CD extension on the cluster</a:t>
+              <a:t>Ensure the K8s-configuration provider + extension CLI are available</a:t>
             </a:r>
           </a:p>
         </p:txBody>
@@ -21530,6 +21542,119 @@
                 </a:solidFill>
                 <a:latin typeface="Calibri"/>
               </a:rPr>
+              <a:t>Install the managed Argo CD extension on the cluster</a:t>
+            </a:r>
+          </a:p>
+        </p:txBody>
+      </p:sp>
+      <p:sp>
+        <p:nvSpPr>
+          <p:cNvPr id="18" name="Oval 17"/>
+          <p:cNvSpPr/>
+          <p:nvPr/>
+        </p:nvSpPr>
+        <p:spPr>
+          <a:xfrm>
+            <a:off x="457200" y="3520440"/>
+            <a:ext cx="384048" cy="384048"/>
+          </a:xfrm>
+          <a:prstGeom prst="ellipse">
+            <a:avLst/>
+          </a:prstGeom>
+          <a:solidFill>
+            <a:srgbClr val="103A6E"/>
+          </a:solidFill>
+          <a:ln>
+            <a:noFill/>
+          </a:ln>
+        </p:spPr>
+        <p:style>
+          <a:lnRef idx="1">
+            <a:schemeClr val="accent1"/>
+          </a:lnRef>
+          <a:fillRef idx="3">
+            <a:schemeClr val="accent1"/>
+          </a:fillRef>
+          <a:effectRef idx="2">
+            <a:schemeClr val="accent1"/>
+          </a:effectRef>
+          <a:fontRef idx="minor">
+            <a:schemeClr val="lt1"/>
+          </a:fontRef>
+        </p:style>
+        <p:txBody>
+          <a:bodyPr rtlCol="0" anchor="ctr"/>
+          <a:lstStyle/>
+          <a:p>
+            <a:pPr algn="ctr"/>
+          </a:p>
+        </p:txBody>
+      </p:sp>
+      <p:sp>
+        <p:nvSpPr>
+          <p:cNvPr id="19" name="TextBox 18"/>
+          <p:cNvSpPr txBox="1"/>
+          <p:nvPr/>
+        </p:nvSpPr>
+        <p:spPr>
+          <a:xfrm>
+            <a:off x="457200" y="3520440"/>
+            <a:ext cx="384048" cy="384048"/>
+          </a:xfrm>
+          <a:prstGeom prst="rect">
+            <a:avLst/>
+          </a:prstGeom>
+          <a:noFill/>
+        </p:spPr>
+        <p:txBody>
+          <a:bodyPr wrap="square" lIns="45720" rIns="45720" tIns="18288" bIns="18288" anchor="ctr">
+            <a:spAutoFit/>
+          </a:bodyPr>
+          <a:lstStyle/>
+          <a:p>
+            <a:pPr algn="ctr"/>
+            <a:r>
+              <a:rPr sz="1400" b="1" i="0">
+                <a:solidFill>
+                  <a:srgbClr val="FFFFFF"/>
+                </a:solidFill>
+                <a:latin typeface="Calibri"/>
+              </a:rPr>
+              <a:t>4</a:t>
+            </a:r>
+          </a:p>
+        </p:txBody>
+      </p:sp>
+      <p:sp>
+        <p:nvSpPr>
+          <p:cNvPr id="20" name="TextBox 19"/>
+          <p:cNvSpPr txBox="1"/>
+          <p:nvPr/>
+        </p:nvSpPr>
+        <p:spPr>
+          <a:xfrm>
+            <a:off x="960120" y="3538728"/>
+            <a:ext cx="6309360" cy="411480"/>
+          </a:xfrm>
+          <a:prstGeom prst="rect">
+            <a:avLst/>
+          </a:prstGeom>
+          <a:noFill/>
+        </p:spPr>
+        <p:txBody>
+          <a:bodyPr wrap="square" lIns="45720" rIns="45720" tIns="18288" bIns="18288" anchor="ctr">
+            <a:spAutoFit/>
+          </a:bodyPr>
+          <a:lstStyle/>
+          <a:p>
+            <a:pPr algn="l"/>
+            <a:r>
+              <a:rPr sz="1300" b="0" i="0">
+                <a:solidFill>
+                  <a:srgbClr val="1F2A44"/>
+                </a:solidFill>
+                <a:latin typeface="Calibri"/>
+              </a:rPr>
               <a:t>Bootstrap an Application from Git</a:t>
             </a:r>
           </a:p>
@@ -21537,7 +21662,7 @@
       </p:sp>
       <p:sp>
         <p:nvSpPr>
-          <p:cNvPr id="18" name="Rounded Rectangle 17"/>
+          <p:cNvPr id="21" name="Rounded Rectangle 20"/>
           <p:cNvSpPr/>
           <p:nvPr/>
         </p:nvSpPr>
@@ -21583,7 +21708,7 @@
       </p:sp>
       <p:sp>
         <p:nvSpPr>
-          <p:cNvPr id="19" name="Rectangle 18"/>
+          <p:cNvPr id="22" name="Rectangle 21"/>
           <p:cNvSpPr/>
           <p:nvPr/>
         </p:nvSpPr>
@@ -21627,7 +21752,7 @@
       </p:sp>
       <p:sp>
         <p:nvSpPr>
-          <p:cNvPr id="20" name="TextBox 19"/>
+          <p:cNvPr id="23" name="TextBox 22"/>
           <p:cNvSpPr txBox="1"/>
           <p:nvPr/>
         </p:nvSpPr>
@@ -21662,7 +21787,7 @@
       </p:sp>
       <p:sp>
         <p:nvSpPr>
-          <p:cNvPr id="21" name="Oval 20"/>
+          <p:cNvPr id="24" name="Oval 23"/>
           <p:cNvSpPr/>
           <p:nvPr/>
         </p:nvSpPr>
@@ -21705,7 +21830,7 @@
       </p:sp>
       <p:sp>
         <p:nvSpPr>
-          <p:cNvPr id="22" name="TextBox 21"/>
+          <p:cNvPr id="25" name="TextBox 24"/>
           <p:cNvSpPr txBox="1"/>
           <p:nvPr/>
         </p:nvSpPr>
@@ -21740,7 +21865,7 @@
       </p:sp>
       <p:sp>
         <p:nvSpPr>
-          <p:cNvPr id="23" name="Oval 22"/>
+          <p:cNvPr id="26" name="Oval 25"/>
           <p:cNvSpPr/>
           <p:nvPr/>
         </p:nvSpPr>
@@ -21783,7 +21908,7 @@
       </p:sp>
       <p:sp>
         <p:nvSpPr>
-          <p:cNvPr id="24" name="TextBox 23"/>
+          <p:cNvPr id="27" name="TextBox 26"/>
           <p:cNvSpPr txBox="1"/>
           <p:nvPr/>
         </p:nvSpPr>
@@ -21818,7 +21943,7 @@
       </p:sp>
       <p:sp>
         <p:nvSpPr>
-          <p:cNvPr id="25" name="Oval 24"/>
+          <p:cNvPr id="28" name="Oval 27"/>
           <p:cNvSpPr/>
           <p:nvPr/>
         </p:nvSpPr>
@@ -21861,7 +21986,7 @@
       </p:sp>
       <p:sp>
         <p:nvSpPr>
-          <p:cNvPr id="26" name="TextBox 25"/>
+          <p:cNvPr id="29" name="TextBox 28"/>
           <p:cNvSpPr txBox="1"/>
           <p:nvPr/>
         </p:nvSpPr>
@@ -21896,7 +22021,7 @@
       </p:sp>
       <p:sp>
         <p:nvSpPr>
-          <p:cNvPr id="27" name="Oval 26"/>
+          <p:cNvPr id="30" name="Oval 29"/>
           <p:cNvSpPr/>
           <p:nvPr/>
         </p:nvSpPr>
@@ -21939,7 +22064,7 @@
       </p:sp>
       <p:sp>
         <p:nvSpPr>
-          <p:cNvPr id="28" name="TextBox 27"/>
+          <p:cNvPr id="31" name="TextBox 30"/>
           <p:cNvSpPr txBox="1"/>
           <p:nvPr/>
         </p:nvSpPr>
@@ -21974,7 +22099,7 @@
       </p:sp>
       <p:sp>
         <p:nvSpPr>
-          <p:cNvPr id="29" name="Rounded Rectangle 28"/>
+          <p:cNvPr id="32" name="Rounded Rectangle 31"/>
           <p:cNvSpPr/>
           <p:nvPr/>
         </p:nvSpPr>
@@ -22022,7 +22147,7 @@
       </p:sp>
       <p:sp>
         <p:nvSpPr>
-          <p:cNvPr id="30" name="TextBox 29"/>
+          <p:cNvPr id="33" name="TextBox 32"/>
           <p:cNvSpPr txBox="1"/>
           <p:nvPr/>
         </p:nvSpPr>
@@ -22057,7 +22182,7 @@
       </p:sp>
       <p:sp>
         <p:nvSpPr>
-          <p:cNvPr id="31" name="TextBox 30"/>
+          <p:cNvPr id="34" name="TextBox 33"/>
           <p:cNvSpPr txBox="1"/>
           <p:nvPr/>
         </p:nvSpPr>
@@ -22140,7 +22265,7 @@
       </p:sp>
       <p:sp>
         <p:nvSpPr>
-          <p:cNvPr id="32" name="Rectangle 31"/>
+          <p:cNvPr id="35" name="Rectangle 34"/>
           <p:cNvSpPr/>
           <p:nvPr/>
         </p:nvSpPr>
@@ -22184,7 +22309,7 @@
       </p:sp>
       <p:sp>
         <p:nvSpPr>
-          <p:cNvPr id="33" name="TextBox 32"/>
+          <p:cNvPr id="36" name="TextBox 35"/>
           <p:cNvSpPr txBox="1"/>
           <p:nvPr/>
         </p:nvSpPr>
@@ -22219,7 +22344,7 @@
       </p:sp>
       <p:sp>
         <p:nvSpPr>
-          <p:cNvPr id="34" name="Rounded Rectangle 33"/>
+          <p:cNvPr id="37" name="Rounded Rectangle 36"/>
           <p:cNvSpPr/>
           <p:nvPr/>
         </p:nvSpPr>
@@ -22265,7 +22390,7 @@
       </p:sp>
       <p:sp>
         <p:nvSpPr>
-          <p:cNvPr id="35" name="TextBox 34"/>
+          <p:cNvPr id="38" name="TextBox 37"/>
           <p:cNvSpPr txBox="1"/>
           <p:nvPr/>
         </p:nvSpPr>
@@ -22300,7 +22425,7 @@
       </p:sp>
       <p:sp>
         <p:nvSpPr>
-          <p:cNvPr id="36" name="TextBox 35"/>
+          <p:cNvPr id="39" name="TextBox 38"/>
           <p:cNvSpPr txBox="1"/>
           <p:nvPr/>
         </p:nvSpPr>
@@ -28905,7 +29030,7 @@
                 </a:solidFill>
                 <a:latin typeface="Calibri"/>
               </a:rPr>
-              <a:t>Create resource group + AKS (Free tier, K8s 1.34.7, Sweden Central)</a:t>
+              <a:t>Create resource group + AKS (Free tier, pinned K8s 1.34.7, Sweden Central)</a:t>
             </a:r>
           </a:p>
         </p:txBody>
@@ -29560,7 +29685,7 @@
                 </a:solidFill>
                 <a:latin typeface="Calibri"/>
               </a:rPr>
-              <a:t>AKS 1.34.7 with Cilium dataplane in Sweden Central</a:t>
+              <a:t>Pinned AKS 1.34.7 with Cilium dataplane in Sweden Central</a:t>
             </a:r>
           </a:p>
         </p:txBody>

</xml_diff>

<commit_message>
docs: validate and trim repository documentation
Sync docs with actual code/config and remove orphaned, transient, or inaccurate docs.

- Fix namespace references (default -> demo) in copilot-instructions, demo
  READMEs, drawio diagrams, and PRESENTATION.md
- Align NGINX manual install with the deploy script (helm upgrade --install,
  Azure LB health-probe annotation, --timeout)
- Pin Envoy Gateway to v1.2.3 and document the missing GatewayClass apply step
- Correct demo-01 deployment name in infra README
- Fix stale Sweden maintenance-window comment in Demo 04 bicep
- Remove App Routing add-on misattribution from Demo 03 diagram
- Fix hardcoded personal path in build_pptx.py and rebuild PRESENTATION.pptx
- Delete orphaned/transient docs: RBAC_CHANGES, REDEPLOY_INSTRUCTIONS,
  AZURE_PORTAL_SETUP, ARCHITECTURE_DIAGRAMS

Co-authored-by: Copilot <223556219+Copilot@users.noreply.github.com>
</commit_message>
<xml_diff>
--- a/PRESENTATION.pptx
+++ b/PRESENTATION.pptx
@@ -628,7 +628,7 @@
           <a:p>
             <a:r>
               <a:rPr sz="1100"/>
-              <a:t>Envoy Gateway is the upstream-reference implementation. The current demo script applies the stable upstream v1.2.3 `install.yaml`, verifies `GatewayClass/envoy-gateway`, then applies the application `Gateway` and `HTTPRoute` in the default namespace. On AKS, Envoy's Service of type LoadBalancer triggers an Azure SLB and public IP — same north-south model you already use, but routing is portable Gateway API YAML rather than controller-specific annotations. The repository deployment flow is split into infra, image build, and Kubernetes configuration phases so only the final phase touches the active `kubectl` context.</a:t>
+              <a:t>Envoy Gateway is the upstream-reference implementation. The current demo script applies the stable upstream v1.2.3 `install.yaml`, verifies `GatewayClass/envoy-gateway`, then applies the application `Gateway` and `HTTPRoute` in the `demo` namespace. On AKS, Envoy's Service of type LoadBalancer triggers an Azure SLB and public IP — same north-south model you already use, but routing is portable Gateway API YAML rather than controller-specific annotations. The repository deployment flow is split into infra, image build, and Kubernetes configuration phases so only the final phase touches the active `kubectl` context.</a:t>
             </a:r>
           </a:p>
           <a:p>
@@ -748,7 +748,7 @@
           <a:p>
             <a:r>
               <a:rPr sz="1100"/>
-              <a:t>metadata: { name: envoy-demo-gateway, namespace: default }</a:t>
+              <a:t>metadata: { name: envoy-demo-gateway, namespace: demo }</a:t>
             </a:r>
           </a:p>
           <a:p>
@@ -820,7 +820,7 @@
           <a:p>
             <a:r>
               <a:rPr sz="1100"/>
-              <a:t>metadata: { name: envoy-demo-route, namespace: default }</a:t>
+              <a:t>metadata: { name: envoy-demo-route, namespace: demo }</a:t>
             </a:r>
           </a:p>
           <a:p>
@@ -1250,7 +1250,7 @@
           <a:p>
             <a:r>
               <a:rPr sz="1100"/>
-              <a:t>  namespace: default</a:t>
+              <a:t>  namespace: demo</a:t>
             </a:r>
           </a:p>
           <a:p>
@@ -1316,7 +1316,7 @@
           <a:p>
             <a:r>
               <a:rPr sz="1100"/>
-              <a:t>metadata: { name: agc-demo-route, namespace: default }</a:t>
+              <a:t>metadata: { name: agc-demo-route, namespace: demo }</a:t>
             </a:r>
           </a:p>
           <a:p>
@@ -15451,7 +15451,7 @@
                 </a:solidFill>
                 <a:latin typeface="Consolas"/>
               </a:rPr>
-              <a:t>    ┌─ Application namespace: default ─────────────────────────────┐</a:t>
+              <a:t>    ┌─ Application namespace: demo ────────────────────────────────┐</a:t>
             </a:r>
           </a:p>
           <a:p>

</xml_diff>